<commit_message>
Deck: show measured HRU inside the target zone on slide 6
Co-Authored-By: Claude Opus 5.5 <noreply@anthropic.com>
</commit_message>
<xml_diff>
--- a/presentation/ForgetBench_HRU_Final.pptx
+++ b/presentation/ForgetBench_HRU_Final.pptx
@@ -1751,7 +1751,7 @@
           <a:p>
             <a:r>
               <a:rPr lang="en-US" dirty="0"/>
-              <a:t>Plot cost against durability: exact methods are durable but expensive; cheap methods collapse under attack; nothing sits in the cheap-and-durable corner. 2–5x is a design target, not a result. Measured HRU so far used 3x a scrub pass — slides 11 and 12.</a:t>
+              <a:t>Plot cost against durability: exact methods are durable but expensive; cheap methods collapse under attack. In prior work nothing sits in the cheap-and-durable corner. Our measured HRU lands there: 3x a scrub pass, the most durable result in the study — Arpith shows it on slide 12.</a:t>
             </a:r>
             <a:endParaRPr lang="en-US" dirty="0"/>
           </a:p>
@@ -20906,7 +20906,7 @@
                 <a:ea typeface="IBM Plex Mono" pitchFamily="34" charset="-122"/>
                 <a:cs typeface="IBM Plex Mono" pitchFamily="34" charset="-120"/>
               </a:rPr>
-              <a:t>UNOCCUPIED</a:t>
+              <a:t>TARGET ZONE</a:t>
             </a:r>
             <a:endParaRPr lang="en-US" sz="1400" dirty="0"/>
           </a:p>
@@ -20948,7 +20948,7 @@
                 <a:ea typeface="IBM Plex Sans" pitchFamily="34" charset="-122"/>
                 <a:cs typeface="IBM Plex Sans" pitchFamily="34" charset="-120"/>
               </a:rPr>
-              <a:t>Cheap enough per request, durable enough to survive fine-tuning.</a:t>
+              <a:t>Cheap enough per request, durable enough to survive fine-tuning. No prior method sits here.</a:t>
             </a:r>
             <a:endParaRPr lang="en-US" sz="1500" dirty="0"/>
           </a:p>
@@ -20956,33 +20956,58 @@
       </p:sp>
       <p:sp>
         <p:nvSpPr>
-          <p:cNvPr id="15" name="Text 13"/>
-          <p:cNvSpPr txBox="1"/>
-          <p:nvPr/>
-        </p:nvSpPr>
-        <p:spPr>
-          <a:xfrm>
-            <a:off x="2313432" y="4617720"/>
-            <a:ext cx="2926080" cy="365760"/>
-          </a:xfrm>
-          <a:prstGeom prst="rect">
-            <a:avLst/>
-          </a:prstGeom>
-          <a:noFill/>
-          <a:ln/>
-        </p:spPr>
-        <p:txBody>
-          <a:bodyPr wrap="square" lIns="0" tIns="0" rIns="0" bIns="0" rtlCol="0" anchor="t"/>
-          <a:lstStyle/>
-          <a:p>
-            <a:pPr algn="l" indent="0" marL="0">
-              <a:lnSpc>
-                <a:spcPct val="108000"/>
-              </a:lnSpc>
-              <a:buNone/>
-            </a:pPr>
-            <a:r>
-              <a:rPr lang="en-US" sz="1300" dirty="0">
+          <p:cNvPr id="15" name="Shape 13"/>
+          <p:cNvSpPr/>
+          <p:nvPr/>
+        </p:nvSpPr>
+        <p:spPr>
+          <a:xfrm>
+            <a:off x="2313432" y="4590288"/>
+            <a:ext cx="274320" cy="274320"/>
+          </a:xfrm>
+          <a:prstGeom prst="ellipse">
+            <a:avLst/>
+          </a:prstGeom>
+          <a:solidFill>
+            <a:srgbClr val="2DD4BF"/>
+          </a:solidFill>
+          <a:ln w="12700">
+            <a:solidFill>
+              <a:srgbClr val="EAF0FA"/>
+            </a:solidFill>
+            <a:prstDash val="solid"/>
+          </a:ln>
+        </p:spPr>
+      </p:sp>
+      <p:sp>
+        <p:nvSpPr>
+          <p:cNvPr id="16" name="Text 14"/>
+          <p:cNvSpPr txBox="1"/>
+          <p:nvPr/>
+        </p:nvSpPr>
+        <p:spPr>
+          <a:xfrm>
+            <a:off x="2679192" y="4553712"/>
+            <a:ext cx="2606040" cy="365760"/>
+          </a:xfrm>
+          <a:prstGeom prst="rect">
+            <a:avLst/>
+          </a:prstGeom>
+          <a:noFill/>
+          <a:ln/>
+        </p:spPr>
+        <p:txBody>
+          <a:bodyPr wrap="square" lIns="0" tIns="0" rIns="0" bIns="0" rtlCol="0" anchor="t"/>
+          <a:lstStyle/>
+          <a:p>
+            <a:pPr algn="l" indent="0" marL="0">
+              <a:lnSpc>
+                <a:spcPct val="108000"/>
+              </a:lnSpc>
+              <a:buNone/>
+            </a:pPr>
+            <a:r>
+              <a:rPr lang="en-US" sz="1200" dirty="0">
                 <a:solidFill>
                   <a:srgbClr val="2DD4BF"/>
                 </a:solidFill>
@@ -20990,15 +21015,15 @@
                 <a:ea typeface="IBM Plex Mono" pitchFamily="34" charset="-122"/>
                 <a:cs typeface="IBM Plex Mono" pitchFamily="34" charset="-120"/>
               </a:rPr>
-              <a:t>HRU · 2–5× design target</a:t>
-            </a:r>
-            <a:endParaRPr lang="en-US" sz="1300" dirty="0"/>
-          </a:p>
-        </p:txBody>
-      </p:sp>
-      <p:sp>
-        <p:nvSpPr>
-          <p:cNvPr id="16" name="Shape 14"/>
+              <a:t>HRU · 3× · measured here (slide 12)</a:t>
+            </a:r>
+            <a:endParaRPr lang="en-US" sz="1200" dirty="0"/>
+          </a:p>
+        </p:txBody>
+      </p:sp>
+      <p:sp>
+        <p:nvSpPr>
+          <p:cNvPr id="17" name="Shape 15"/>
           <p:cNvSpPr/>
           <p:nvPr/>
         </p:nvSpPr>
@@ -21023,7 +21048,7 @@
       </p:sp>
       <p:sp>
         <p:nvSpPr>
-          <p:cNvPr id="17" name="Text 15"/>
+          <p:cNvPr id="18" name="Text 16"/>
           <p:cNvSpPr txBox="1"/>
           <p:nvPr/>
         </p:nvSpPr>
@@ -21065,7 +21090,7 @@
       </p:sp>
       <p:sp>
         <p:nvSpPr>
-          <p:cNvPr id="18" name="Text 16"/>
+          <p:cNvPr id="19" name="Text 17"/>
           <p:cNvSpPr txBox="1"/>
           <p:nvPr/>
         </p:nvSpPr>
@@ -21107,7 +21132,7 @@
       </p:sp>
       <p:sp>
         <p:nvSpPr>
-          <p:cNvPr id="19" name="Shape 17"/>
+          <p:cNvPr id="20" name="Shape 18"/>
           <p:cNvSpPr/>
           <p:nvPr/>
         </p:nvSpPr>
@@ -21132,7 +21157,7 @@
       </p:sp>
       <p:sp>
         <p:nvSpPr>
-          <p:cNvPr id="20" name="Text 18"/>
+          <p:cNvPr id="21" name="Text 19"/>
           <p:cNvSpPr txBox="1"/>
           <p:nvPr/>
         </p:nvSpPr>
@@ -21174,7 +21199,7 @@
       </p:sp>
       <p:sp>
         <p:nvSpPr>
-          <p:cNvPr id="21" name="Text 19"/>
+          <p:cNvPr id="22" name="Text 20"/>
           <p:cNvSpPr txBox="1"/>
           <p:nvPr/>
         </p:nvSpPr>
@@ -21216,7 +21241,7 @@
       </p:sp>
       <p:sp>
         <p:nvSpPr>
-          <p:cNvPr id="22" name="Shape 20"/>
+          <p:cNvPr id="23" name="Shape 21"/>
           <p:cNvSpPr/>
           <p:nvPr/>
         </p:nvSpPr>
@@ -21241,7 +21266,7 @@
       </p:sp>
       <p:sp>
         <p:nvSpPr>
-          <p:cNvPr id="23" name="Text 21"/>
+          <p:cNvPr id="24" name="Text 22"/>
           <p:cNvSpPr txBox="1"/>
           <p:nvPr/>
         </p:nvSpPr>
@@ -21283,7 +21308,7 @@
       </p:sp>
       <p:sp>
         <p:nvSpPr>
-          <p:cNvPr id="24" name="Text 22"/>
+          <p:cNvPr id="25" name="Text 23"/>
           <p:cNvSpPr txBox="1"/>
           <p:nvPr/>
         </p:nvSpPr>
@@ -21325,7 +21350,7 @@
       </p:sp>
       <p:sp>
         <p:nvSpPr>
-          <p:cNvPr id="25" name="Shape 23"/>
+          <p:cNvPr id="26" name="Shape 24"/>
           <p:cNvSpPr/>
           <p:nvPr/>
         </p:nvSpPr>
@@ -21350,7 +21375,7 @@
       </p:sp>
       <p:sp>
         <p:nvSpPr>
-          <p:cNvPr id="26" name="Text 24"/>
+          <p:cNvPr id="27" name="Text 25"/>
           <p:cNvSpPr txBox="1"/>
           <p:nvPr/>
         </p:nvSpPr>
@@ -21392,7 +21417,7 @@
       </p:sp>
       <p:sp>
         <p:nvSpPr>
-          <p:cNvPr id="27" name="Text 25"/>
+          <p:cNvPr id="28" name="Text 26"/>
           <p:cNvSpPr txBox="1"/>
           <p:nvPr/>
         </p:nvSpPr>
@@ -21434,7 +21459,7 @@
       </p:sp>
       <p:sp>
         <p:nvSpPr>
-          <p:cNvPr id="28" name="Shape 26"/>
+          <p:cNvPr id="29" name="Shape 27"/>
           <p:cNvSpPr/>
           <p:nvPr/>
         </p:nvSpPr>
@@ -21461,7 +21486,7 @@
       </p:sp>
       <p:sp>
         <p:nvSpPr>
-          <p:cNvPr id="29" name="Text 27"/>
+          <p:cNvPr id="30" name="Text 28"/>
           <p:cNvSpPr txBox="1"/>
           <p:nvPr/>
         </p:nvSpPr>
@@ -21503,7 +21528,7 @@
       </p:sp>
       <p:sp>
         <p:nvSpPr>
-          <p:cNvPr id="30" name="Text 28"/>
+          <p:cNvPr id="31" name="Text 29"/>
           <p:cNvSpPr txBox="1"/>
           <p:nvPr/>
         </p:nvSpPr>
@@ -21545,7 +21570,7 @@
       </p:sp>
       <p:sp>
         <p:nvSpPr>
-          <p:cNvPr id="31" name="Text 29"/>
+          <p:cNvPr id="32" name="Text 30"/>
           <p:cNvSpPr txBox="1"/>
           <p:nvPr/>
         </p:nvSpPr>
@@ -21587,7 +21612,7 @@
       </p:sp>
       <p:sp>
         <p:nvSpPr>
-          <p:cNvPr id="32" name="Shape 30"/>
+          <p:cNvPr id="33" name="Shape 31"/>
           <p:cNvSpPr/>
           <p:nvPr/>
         </p:nvSpPr>
@@ -21614,7 +21639,7 @@
       </p:sp>
       <p:sp>
         <p:nvSpPr>
-          <p:cNvPr id="33" name="Text 31"/>
+          <p:cNvPr id="34" name="Text 32"/>
           <p:cNvSpPr txBox="1"/>
           <p:nvPr/>
         </p:nvSpPr>
@@ -21656,7 +21681,7 @@
       </p:sp>
       <p:sp>
         <p:nvSpPr>
-          <p:cNvPr id="34" name="Text 32"/>
+          <p:cNvPr id="35" name="Text 33"/>
           <p:cNvSpPr txBox="1"/>
           <p:nvPr/>
         </p:nvSpPr>
@@ -21698,7 +21723,7 @@
       </p:sp>
       <p:sp>
         <p:nvSpPr>
-          <p:cNvPr id="35" name="Text 33"/>
+          <p:cNvPr id="36" name="Text 34"/>
           <p:cNvSpPr txBox="1"/>
           <p:nvPr/>
         </p:nvSpPr>
@@ -21740,7 +21765,7 @@
       </p:sp>
       <p:sp>
         <p:nvSpPr>
-          <p:cNvPr id="36" name="Shape 34"/>
+          <p:cNvPr id="37" name="Shape 35"/>
           <p:cNvSpPr/>
           <p:nvPr/>
         </p:nvSpPr>
@@ -21767,7 +21792,7 @@
       </p:sp>
       <p:sp>
         <p:nvSpPr>
-          <p:cNvPr id="37" name="Text 35"/>
+          <p:cNvPr id="38" name="Text 36"/>
           <p:cNvSpPr txBox="1"/>
           <p:nvPr/>
         </p:nvSpPr>
@@ -21809,7 +21834,7 @@
       </p:sp>
       <p:sp>
         <p:nvSpPr>
-          <p:cNvPr id="38" name="Text 36"/>
+          <p:cNvPr id="39" name="Text 37"/>
           <p:cNvSpPr txBox="1"/>
           <p:nvPr/>
         </p:nvSpPr>
@@ -21851,7 +21876,7 @@
       </p:sp>
       <p:sp>
         <p:nvSpPr>
-          <p:cNvPr id="39" name="Text 37"/>
+          <p:cNvPr id="40" name="Text 38"/>
           <p:cNvSpPr txBox="1"/>
           <p:nvPr/>
         </p:nvSpPr>

</xml_diff>